<commit_message>
Add year switcher, metric refactor & edit history
Pass financial statements to editor and allow switching years in EditFinancials (adds currentStatementId, resets pending edits on switch, warns on unsaved changes, and uses currentStatementId for saves). Move and style the edit history into the EditFinancials page and adjust layout (padding, sticky footer z-index).

Refactor metrics UI: replace KPICard/RatioCard usages with the unified MetricCard, add getChartData and improved yoyChange handling (supporting ratios), and add a hideChart prop to MetricCard to hide charts for non-numeric cards. Update imports and types accordingly. Minor formatting/structure cleanup in RatingComparison.
</commit_message>
<xml_diff>
--- a/UI_Screenshots.pptx
+++ b/UI_Screenshots.pptx
@@ -111,6 +111,11 @@
       </a:defRPr>
     </a:lvl9pPr>
   </p:defaultTextStyle>
+  <p:extLst>
+    <p:ext uri="{EFAFB233-063F-42B5-8137-9DF3F51BA10A}">
+      <p15:sldGuideLst xmlns:p15="http://schemas.microsoft.com/office/powerpoint/2012/main"/>
+    </p:ext>
+  </p:extLst>
 </p:presentation>
 </file>
 
@@ -263,7 +268,7 @@
           <a:p>
             <a:fld id="{EC23457E-23D0-454C-89D5-7C22AFA0DC8A}" type="datetimeFigureOut">
               <a:rPr lang="en-AE" smtClean="0"/>
-              <a:t>27/02/2026</a:t>
+              <a:t>13/03/2026</a:t>
             </a:fld>
             <a:endParaRPr lang="en-AE"/>
           </a:p>
@@ -463,7 +468,7 @@
           <a:p>
             <a:fld id="{EC23457E-23D0-454C-89D5-7C22AFA0DC8A}" type="datetimeFigureOut">
               <a:rPr lang="en-AE" smtClean="0"/>
-              <a:t>27/02/2026</a:t>
+              <a:t>13/03/2026</a:t>
             </a:fld>
             <a:endParaRPr lang="en-AE"/>
           </a:p>
@@ -673,7 +678,7 @@
           <a:p>
             <a:fld id="{EC23457E-23D0-454C-89D5-7C22AFA0DC8A}" type="datetimeFigureOut">
               <a:rPr lang="en-AE" smtClean="0"/>
-              <a:t>27/02/2026</a:t>
+              <a:t>13/03/2026</a:t>
             </a:fld>
             <a:endParaRPr lang="en-AE"/>
           </a:p>
@@ -873,7 +878,7 @@
           <a:p>
             <a:fld id="{EC23457E-23D0-454C-89D5-7C22AFA0DC8A}" type="datetimeFigureOut">
               <a:rPr lang="en-AE" smtClean="0"/>
-              <a:t>27/02/2026</a:t>
+              <a:t>13/03/2026</a:t>
             </a:fld>
             <a:endParaRPr lang="en-AE"/>
           </a:p>
@@ -1149,7 +1154,7 @@
           <a:p>
             <a:fld id="{EC23457E-23D0-454C-89D5-7C22AFA0DC8A}" type="datetimeFigureOut">
               <a:rPr lang="en-AE" smtClean="0"/>
-              <a:t>27/02/2026</a:t>
+              <a:t>13/03/2026</a:t>
             </a:fld>
             <a:endParaRPr lang="en-AE"/>
           </a:p>
@@ -1417,7 +1422,7 @@
           <a:p>
             <a:fld id="{EC23457E-23D0-454C-89D5-7C22AFA0DC8A}" type="datetimeFigureOut">
               <a:rPr lang="en-AE" smtClean="0"/>
-              <a:t>27/02/2026</a:t>
+              <a:t>13/03/2026</a:t>
             </a:fld>
             <a:endParaRPr lang="en-AE"/>
           </a:p>
@@ -1832,7 +1837,7 @@
           <a:p>
             <a:fld id="{EC23457E-23D0-454C-89D5-7C22AFA0DC8A}" type="datetimeFigureOut">
               <a:rPr lang="en-AE" smtClean="0"/>
-              <a:t>27/02/2026</a:t>
+              <a:t>13/03/2026</a:t>
             </a:fld>
             <a:endParaRPr lang="en-AE"/>
           </a:p>
@@ -1974,7 +1979,7 @@
           <a:p>
             <a:fld id="{EC23457E-23D0-454C-89D5-7C22AFA0DC8A}" type="datetimeFigureOut">
               <a:rPr lang="en-AE" smtClean="0"/>
-              <a:t>27/02/2026</a:t>
+              <a:t>13/03/2026</a:t>
             </a:fld>
             <a:endParaRPr lang="en-AE"/>
           </a:p>
@@ -2087,7 +2092,7 @@
           <a:p>
             <a:fld id="{EC23457E-23D0-454C-89D5-7C22AFA0DC8A}" type="datetimeFigureOut">
               <a:rPr lang="en-AE" smtClean="0"/>
-              <a:t>27/02/2026</a:t>
+              <a:t>13/03/2026</a:t>
             </a:fld>
             <a:endParaRPr lang="en-AE"/>
           </a:p>
@@ -2400,7 +2405,7 @@
           <a:p>
             <a:fld id="{EC23457E-23D0-454C-89D5-7C22AFA0DC8A}" type="datetimeFigureOut">
               <a:rPr lang="en-AE" smtClean="0"/>
-              <a:t>27/02/2026</a:t>
+              <a:t>13/03/2026</a:t>
             </a:fld>
             <a:endParaRPr lang="en-AE"/>
           </a:p>
@@ -2689,7 +2694,7 @@
           <a:p>
             <a:fld id="{EC23457E-23D0-454C-89D5-7C22AFA0DC8A}" type="datetimeFigureOut">
               <a:rPr lang="en-AE" smtClean="0"/>
-              <a:t>27/02/2026</a:t>
+              <a:t>13/03/2026</a:t>
             </a:fld>
             <a:endParaRPr lang="en-AE"/>
           </a:p>
@@ -2932,7 +2937,7 @@
           <a:p>
             <a:fld id="{EC23457E-23D0-454C-89D5-7C22AFA0DC8A}" type="datetimeFigureOut">
               <a:rPr lang="en-AE" smtClean="0"/>
-              <a:t>27/02/2026</a:t>
+              <a:t>13/03/2026</a:t>
             </a:fld>
             <a:endParaRPr lang="en-AE"/>
           </a:p>
@@ -3451,7 +3456,7 @@
         </p:blipFill>
         <p:spPr>
           <a:xfrm>
-            <a:off x="218773" y="263362"/>
+            <a:off x="141771" y="263362"/>
             <a:ext cx="11754454" cy="6331275"/>
           </a:xfrm>
           <a:prstGeom prst="rect">
@@ -3891,7 +3896,7 @@
         </p:blipFill>
         <p:spPr>
           <a:xfrm>
-            <a:off x="5253" y="87087"/>
+            <a:off x="0" y="0"/>
             <a:ext cx="12121974" cy="6651170"/>
           </a:xfrm>
           <a:prstGeom prst="rect">

</xml_diff>